<commit_message>
feat(deck): turn qualitative evidence into commitments
</commit_message>
<xml_diff>
--- a/artifacts/spikes/intent-profile-review-2026-07-15/board-presentation.pptx
+++ b/artifacts/spikes/intent-profile-review-2026-07-15/board-presentation.pptx
@@ -4195,7 +4195,7 @@
         <p:spPr>
           <a:xfrm>
             <a:off x="658368" y="1143000"/>
-            <a:ext cx="6675120" cy="1463040"/>
+            <a:ext cx="5394960" cy="1463040"/>
           </a:xfrm>
           <a:prstGeom prst="rect">
             <a:avLst/>
@@ -4236,7 +4236,7 @@
         <p:spPr>
           <a:xfrm>
             <a:off x="685800" y="2788920"/>
-            <a:ext cx="6400800" cy="1508760"/>
+            <a:ext cx="5257800" cy="1508760"/>
           </a:xfrm>
           <a:prstGeom prst="rect">
             <a:avLst/>
@@ -4262,7 +4262,7 @@
                 <a:ea typeface="Arial" pitchFamily="34" charset="-122"/>
                 <a:cs typeface="Arial" pitchFamily="34" charset="-120"/>
               </a:rPr>
-              <a:t>The Code of Conduct covers attendees, speakers, sponsors, and volunteers. The current privacy policy governs event registration data and media use.</a:t>
+              <a:t>Two published policies set the operating baseline for the first event.</a:t>
             </a:r>
             <a:endParaRPr lang="en-US" sz="1800" dirty="0"/>
           </a:p>
@@ -4276,8 +4276,8 @@
         </p:nvSpPr>
         <p:spPr>
           <a:xfrm>
-            <a:off x="7818120" y="658368"/>
-            <a:ext cx="3703320" cy="5440680"/>
+            <a:off x="6492240" y="1078992"/>
+            <a:ext cx="4983480" cy="1572768"/>
           </a:xfrm>
           <a:prstGeom prst="rect">
             <a:avLst/>
@@ -4301,8 +4301,8 @@
         </p:nvSpPr>
         <p:spPr>
           <a:xfrm>
-            <a:off x="8183880" y="3886200"/>
-            <a:ext cx="2880360" cy="201168"/>
+            <a:off x="6748272" y="1773936"/>
+            <a:ext cx="384048" cy="182880"/>
           </a:xfrm>
           <a:prstGeom prst="rect">
             <a:avLst/>
@@ -4318,7 +4318,7 @@
               <a:buNone/>
             </a:pPr>
             <a:r>
-              <a:rPr lang="en-US" sz="800" b="1" spc="120" kern="0" dirty="0">
+              <a:rPr lang="en-US" sz="800" b="1" dirty="0">
                 <a:solidFill>
                   <a:srgbClr val="FF640D"/>
                 </a:solidFill>
@@ -4326,7 +4326,7 @@
                 <a:ea typeface="Arial" pitchFamily="34" charset="-122"/>
                 <a:cs typeface="Arial" pitchFamily="34" charset="-120"/>
               </a:rPr>
-              <a:t>SOURCE-BACKED</a:t>
+              <a:t>01</a:t>
             </a:r>
             <a:endParaRPr lang="en-US" sz="800" dirty="0"/>
           </a:p>
@@ -4340,49 +4340,8 @@
         </p:nvSpPr>
         <p:spPr>
           <a:xfrm>
-            <a:off x="8156448" y="4315968"/>
-            <a:ext cx="2834640" cy="1051560"/>
-          </a:xfrm>
-          <a:prstGeom prst="rect">
-            <a:avLst/>
-          </a:prstGeom>
-          <a:noFill/>
-          <a:ln/>
-        </p:spPr>
-        <p:txBody>
-          <a:bodyPr wrap="square" lIns="0" tIns="0" rIns="0" bIns="0" rtlCol="0" anchor="b">
-            <a:normAutofit/>
-          </a:bodyPr>
-          <a:lstStyle/>
-          <a:p>
-            <a:pPr indent="0" marL="0">
-              <a:buNone/>
-            </a:pPr>
-            <a:r>
-              <a:rPr lang="en-US" sz="2000" dirty="0">
-                <a:solidFill>
-                  <a:srgbClr val="FAF8F3"/>
-                </a:solidFill>
-                <a:latin typeface="Arial" pitchFamily="34" charset="0"/>
-                <a:ea typeface="Arial" pitchFamily="34" charset="-122"/>
-                <a:cs typeface="Arial" pitchFamily="34" charset="-120"/>
-              </a:rPr>
-              <a:t>AI Collective · Conduct and Privacy policies</a:t>
-            </a:r>
-            <a:endParaRPr lang="en-US" sz="2000" dirty="0"/>
-          </a:p>
-        </p:txBody>
-      </p:sp>
-      <p:sp>
-        <p:nvSpPr>
-          <p:cNvPr id="9" name="Text 7"/>
-          <p:cNvSpPr/>
-          <p:nvPr/>
-        </p:nvSpPr>
-        <p:spPr>
-          <a:xfrm>
-            <a:off x="658368" y="6547104"/>
-            <a:ext cx="9966960" cy="164592"/>
+            <a:off x="7333488" y="1280160"/>
+            <a:ext cx="3703320" cy="1170432"/>
           </a:xfrm>
           <a:prstGeom prst="rect">
             <a:avLst/>
@@ -4400,6 +4359,152 @@
               <a:buNone/>
             </a:pPr>
             <a:r>
+              <a:rPr lang="en-US" sz="1600" dirty="0">
+                <a:solidFill>
+                  <a:srgbClr val="FAF8F3"/>
+                </a:solidFill>
+                <a:latin typeface="Arial" pitchFamily="34" charset="0"/>
+                <a:ea typeface="Arial" pitchFamily="34" charset="-122"/>
+                <a:cs typeface="Arial" pitchFamily="34" charset="-120"/>
+              </a:rPr>
+              <a:t>Conduct applies to attendees, speakers, sponsors, and volunteers</a:t>
+            </a:r>
+            <a:endParaRPr lang="en-US" sz="1600" dirty="0"/>
+          </a:p>
+        </p:txBody>
+      </p:sp>
+      <p:sp>
+        <p:nvSpPr>
+          <p:cNvPr id="9" name="Shape 7"/>
+          <p:cNvSpPr/>
+          <p:nvPr/>
+        </p:nvSpPr>
+        <p:spPr>
+          <a:xfrm>
+            <a:off x="6492240" y="2816352"/>
+            <a:ext cx="4983480" cy="1572768"/>
+          </a:xfrm>
+          <a:prstGeom prst="rect">
+            <a:avLst/>
+          </a:prstGeom>
+          <a:solidFill>
+            <a:srgbClr val="171717"/>
+          </a:solidFill>
+          <a:ln w="12700">
+            <a:solidFill>
+              <a:srgbClr val="171717"/>
+            </a:solidFill>
+            <a:prstDash val="solid"/>
+          </a:ln>
+        </p:spPr>
+      </p:sp>
+      <p:sp>
+        <p:nvSpPr>
+          <p:cNvPr id="10" name="Text 8"/>
+          <p:cNvSpPr/>
+          <p:nvPr/>
+        </p:nvSpPr>
+        <p:spPr>
+          <a:xfrm>
+            <a:off x="6748272" y="3511296"/>
+            <a:ext cx="384048" cy="182880"/>
+          </a:xfrm>
+          <a:prstGeom prst="rect">
+            <a:avLst/>
+          </a:prstGeom>
+          <a:noFill/>
+          <a:ln/>
+        </p:spPr>
+        <p:txBody>
+          <a:bodyPr wrap="square" lIns="0" tIns="0" rIns="0" bIns="0" rtlCol="0" anchor="ctr"/>
+          <a:lstStyle/>
+          <a:p>
+            <a:pPr indent="0" marL="0">
+              <a:buNone/>
+            </a:pPr>
+            <a:r>
+              <a:rPr lang="en-US" sz="800" b="1" dirty="0">
+                <a:solidFill>
+                  <a:srgbClr val="FF640D"/>
+                </a:solidFill>
+                <a:latin typeface="Arial" pitchFamily="34" charset="0"/>
+                <a:ea typeface="Arial" pitchFamily="34" charset="-122"/>
+                <a:cs typeface="Arial" pitchFamily="34" charset="-120"/>
+              </a:rPr>
+              <a:t>02</a:t>
+            </a:r>
+            <a:endParaRPr lang="en-US" sz="800" dirty="0"/>
+          </a:p>
+        </p:txBody>
+      </p:sp>
+      <p:sp>
+        <p:nvSpPr>
+          <p:cNvPr id="11" name="Text 9"/>
+          <p:cNvSpPr/>
+          <p:nvPr/>
+        </p:nvSpPr>
+        <p:spPr>
+          <a:xfrm>
+            <a:off x="7333488" y="3017520"/>
+            <a:ext cx="3703320" cy="1170432"/>
+          </a:xfrm>
+          <a:prstGeom prst="rect">
+            <a:avLst/>
+          </a:prstGeom>
+          <a:noFill/>
+          <a:ln/>
+        </p:spPr>
+        <p:txBody>
+          <a:bodyPr wrap="square" lIns="0" tIns="0" rIns="0" bIns="0" rtlCol="0" anchor="ctr">
+            <a:normAutofit/>
+          </a:bodyPr>
+          <a:lstStyle/>
+          <a:p>
+            <a:pPr indent="0" marL="0">
+              <a:buNone/>
+            </a:pPr>
+            <a:r>
+              <a:rPr lang="en-US" sz="1600" dirty="0">
+                <a:solidFill>
+                  <a:srgbClr val="FAF8F3"/>
+                </a:solidFill>
+                <a:latin typeface="Arial" pitchFamily="34" charset="0"/>
+                <a:ea typeface="Arial" pitchFamily="34" charset="-122"/>
+                <a:cs typeface="Arial" pitchFamily="34" charset="-120"/>
+              </a:rPr>
+              <a:t>Privacy rules cover registration data and media use</a:t>
+            </a:r>
+            <a:endParaRPr lang="en-US" sz="1600" dirty="0"/>
+          </a:p>
+        </p:txBody>
+      </p:sp>
+      <p:sp>
+        <p:nvSpPr>
+          <p:cNvPr id="12" name="Text 10"/>
+          <p:cNvSpPr/>
+          <p:nvPr/>
+        </p:nvSpPr>
+        <p:spPr>
+          <a:xfrm>
+            <a:off x="658368" y="6547104"/>
+            <a:ext cx="9966960" cy="164592"/>
+          </a:xfrm>
+          <a:prstGeom prst="rect">
+            <a:avLst/>
+          </a:prstGeom>
+          <a:noFill/>
+          <a:ln/>
+        </p:spPr>
+        <p:txBody>
+          <a:bodyPr wrap="square" lIns="0" tIns="0" rIns="0" bIns="0" rtlCol="0" anchor="ctr">
+            <a:normAutofit/>
+          </a:bodyPr>
+          <a:lstStyle/>
+          <a:p>
+            <a:pPr indent="0" marL="0">
+              <a:buNone/>
+            </a:pPr>
+            <a:r>
               <a:rPr lang="en-US" sz="800" dirty="0">
                 <a:solidFill>
                   <a:srgbClr val="171717">
@@ -4418,7 +4523,7 @@
       </p:sp>
       <p:sp>
         <p:nvSpPr>
-          <p:cNvPr id="10" name="Text 8"/>
+          <p:cNvPr id="13" name="Text 11"/>
           <p:cNvSpPr/>
           <p:nvPr/>
         </p:nvSpPr>

</xml_diff>